<commit_message>
Deck appendix B: new violation type names
</commit_message>
<xml_diff>
--- a/presentations/CashGuard/CashGuard_ForteWin.pptx
+++ b/presentations/CashGuard/CashGuard_ForteWin.pptx
@@ -9331,7 +9331,7 @@
               </a:defRPr>
             </a:pPr>
             <a:r>
-              <a:t>Ушёл, оставив наличные без присмотра</a:t>
+              <a:t>Наличные и ценности без присмотра при уходе</a:t>
             </a:r>
           </a:p>
           <a:p>
@@ -9347,7 +9347,7 @@
               </a:defRPr>
             </a:pPr>
             <a:r>
-              <a:t>Экран рабочей станции не погашен при уходе</a:t>
+              <a:t>Рабочий компьютер не заблокирован при уходе</a:t>
             </a:r>
           </a:p>
           <a:p>
@@ -9363,7 +9363,7 @@
               </a:defRPr>
             </a:pPr>
             <a:r>
-              <a:t>Дверь кассы не закрыта</a:t>
+              <a:t>Дверь кассового помещения не закрыта</a:t>
             </a:r>
           </a:p>
           <a:p>
@@ -9379,7 +9379,7 @@
               </a:defRPr>
             </a:pPr>
             <a:r>
-              <a:t>Постороннее лицо в кассовом помещении</a:t>
+              <a:t>Посторонний в кассовом помещении</a:t>
             </a:r>
           </a:p>
           <a:p>
@@ -9395,7 +9395,7 @@
               </a:defRPr>
             </a:pPr>
             <a:r>
-              <a:t>Клиент ушёл до завершения операции</a:t>
+              <a:t>Пересчёт наличных не в присутствии клиента</a:t>
             </a:r>
           </a:p>
           <a:p>
@@ -9411,7 +9411,7 @@
               </a:defRPr>
             </a:pPr>
             <a:r>
-              <a:t>Деньги прошлого клиента на столе</a:t>
+              <a:t>Наличные прошлого клиента на столе</a:t>
             </a:r>
           </a:p>
         </p:txBody>
@@ -9482,7 +9482,7 @@
               </a:defRPr>
             </a:pPr>
             <a:r>
-              <a:t>Еда / напитки на рабочем месте</a:t>
+              <a:t>Еда и напитки на рабочем месте кассира</a:t>
             </a:r>
           </a:p>
           <a:p>
@@ -9498,7 +9498,7 @@
               </a:defRPr>
             </a:pPr>
             <a:r>
-              <a:t>Кассир ушёл, клиент ждёт</a:t>
+              <a:t>Кассир ушёл, не завершив обслуживание</a:t>
             </a:r>
           </a:p>
           <a:p>
@@ -9514,7 +9514,7 @@
               </a:defRPr>
             </a:pPr>
             <a:r>
-              <a:t>Телефон в руках кассира</a:t>
+              <a:t>Мобильный телефон у кассира</a:t>
             </a:r>
           </a:p>
           <a:p>

</xml_diff>

<commit_message>
Deck: team name YeahGrinders
</commit_message>
<xml_diff>
--- a/presentations/CashGuard/CashGuard_ForteWin.pptx
+++ b/presentations/CashGuard/CashGuard_ForteWin.pptx
@@ -4803,7 +4803,7 @@
               </a:defRPr>
             </a:pPr>
             <a:r>
-              <a:t>FORTEWIN  /  КЕЙС FORTEBANK</a:t>
+              <a:t>YEAHGRINDERS  /  КЕЙС FORTEBANK</a:t>
             </a:r>
           </a:p>
         </p:txBody>
@@ -5099,7 +5099,7 @@
               </a:defRPr>
             </a:pPr>
             <a:r>
-              <a:t>КОМАНДА FORTEWIN</a:t>
+              <a:t>КОМАНДА YEAHGRINDERS</a:t>
             </a:r>
           </a:p>
         </p:txBody>
@@ -5309,7 +5309,7 @@
               </a:defRPr>
             </a:pPr>
             <a:r>
-              <a:t>FORTEWIN  /  КЕЙС FORTEBANK</a:t>
+              <a:t>YEAHGRINDERS  /  КЕЙС FORTEBANK</a:t>
             </a:r>
           </a:p>
         </p:txBody>
@@ -6208,7 +6208,7 @@
               </a:defRPr>
             </a:pPr>
             <a:r>
-              <a:t>FORTEWIN  /  КЕЙС FORTEBANK</a:t>
+              <a:t>YEAHGRINDERS  /  КЕЙС FORTEBANK</a:t>
             </a:r>
           </a:p>
         </p:txBody>
@@ -6996,7 +6996,7 @@
               </a:defRPr>
             </a:pPr>
             <a:r>
-              <a:t>FORTEWIN  /  КЕЙС FORTEBANK</a:t>
+              <a:t>YEAHGRINDERS  /  КЕЙС FORTEBANK</a:t>
             </a:r>
           </a:p>
         </p:txBody>
@@ -7896,7 +7896,7 @@
               </a:defRPr>
             </a:pPr>
             <a:r>
-              <a:t>FORTEWIN  /  КЕЙС FORTEBANK</a:t>
+              <a:t>YEAHGRINDERS  /  КЕЙС FORTEBANK</a:t>
             </a:r>
           </a:p>
         </p:txBody>
@@ -8386,7 +8386,7 @@
               </a:defRPr>
             </a:pPr>
             <a:r>
-              <a:t>FORTEWIN  /  КЕЙС FORTEBANK</a:t>
+              <a:t>YEAHGRINDERS  /  КЕЙС FORTEBANK</a:t>
             </a:r>
           </a:p>
         </p:txBody>
@@ -9081,7 +9081,7 @@
               </a:defRPr>
             </a:pPr>
             <a:r>
-              <a:t>FORTEWIN  /  КЕЙС FORTEBANK</a:t>
+              <a:t>YEAHGRINDERS  /  КЕЙС FORTEBANK</a:t>
             </a:r>
           </a:p>
         </p:txBody>
@@ -9740,7 +9740,7 @@
               </a:defRPr>
             </a:pPr>
             <a:r>
-              <a:t>FORTEWIN  /  КЕЙС FORTEBANK</a:t>
+              <a:t>YEAHGRINDERS  /  КЕЙС FORTEBANK</a:t>
             </a:r>
           </a:p>
         </p:txBody>
@@ -10607,7 +10607,7 @@
               </a:defRPr>
             </a:pPr>
             <a:r>
-              <a:t>FORTEWIN  /  КЕЙС FORTEBANK</a:t>
+              <a:t>YEAHGRINDERS  /  КЕЙС FORTEBANK</a:t>
             </a:r>
           </a:p>
         </p:txBody>
@@ -11140,7 +11140,7 @@
               </a:defRPr>
             </a:pPr>
             <a:r>
-              <a:t>FORTEWIN  /  КЕЙС FORTEBANK</a:t>
+              <a:t>YEAHGRINDERS  /  КЕЙС FORTEBANK</a:t>
             </a:r>
           </a:p>
         </p:txBody>
@@ -12340,7 +12340,7 @@
               </a:defRPr>
             </a:pPr>
             <a:r>
-              <a:t>FORTEWIN  /  КЕЙС FORTEBANK</a:t>
+              <a:t>YEAHGRINDERS  /  КЕЙС FORTEBANK</a:t>
             </a:r>
           </a:p>
         </p:txBody>
@@ -13646,7 +13646,7 @@
               </a:defRPr>
             </a:pPr>
             <a:r>
-              <a:t>FORTEWIN  /  КЕЙС FORTEBANK</a:t>
+              <a:t>YEAHGRINDERS  /  КЕЙС FORTEBANK</a:t>
             </a:r>
           </a:p>
         </p:txBody>
@@ -14561,7 +14561,7 @@
               </a:defRPr>
             </a:pPr>
             <a:r>
-              <a:t>FORTEWIN  /  КЕЙС FORTEBANK</a:t>
+              <a:t>YEAHGRINDERS  /  КЕЙС FORTEBANK</a:t>
             </a:r>
           </a:p>
         </p:txBody>
@@ -15733,7 +15733,7 @@
               </a:defRPr>
             </a:pPr>
             <a:r>
-              <a:t>FORTEWIN  /  КЕЙС FORTEBANK</a:t>
+              <a:t>YEAHGRINDERS  /  КЕЙС FORTEBANK</a:t>
             </a:r>
           </a:p>
         </p:txBody>
@@ -16616,7 +16616,7 @@
               </a:defRPr>
             </a:pPr>
             <a:r>
-              <a:t>FORTEWIN  /  КЕЙС FORTEBANK</a:t>
+              <a:t>YEAHGRINDERS  /  КЕЙС FORTEBANK</a:t>
             </a:r>
           </a:p>
         </p:txBody>

</xml_diff>